<commit_message>
Adding local file to repo
</commit_message>
<xml_diff>
--- a/Presentation1.pptx
+++ b/Presentation1.pptx
@@ -263,7 +263,7 @@
           <a:p>
             <a:fld id="{A43BE092-F41F-4496-B850-05C99CFB8755}" type="datetimeFigureOut">
               <a:rPr lang="en-IN" smtClean="0"/>
-              <a:t>12-05-2026</a:t>
+              <a:t>16-05-2026</a:t>
             </a:fld>
             <a:endParaRPr lang="en-IN"/>
           </a:p>
@@ -463,7 +463,7 @@
           <a:p>
             <a:fld id="{A43BE092-F41F-4496-B850-05C99CFB8755}" type="datetimeFigureOut">
               <a:rPr lang="en-IN" smtClean="0"/>
-              <a:t>12-05-2026</a:t>
+              <a:t>16-05-2026</a:t>
             </a:fld>
             <a:endParaRPr lang="en-IN"/>
           </a:p>
@@ -673,7 +673,7 @@
           <a:p>
             <a:fld id="{A43BE092-F41F-4496-B850-05C99CFB8755}" type="datetimeFigureOut">
               <a:rPr lang="en-IN" smtClean="0"/>
-              <a:t>12-05-2026</a:t>
+              <a:t>16-05-2026</a:t>
             </a:fld>
             <a:endParaRPr lang="en-IN"/>
           </a:p>
@@ -873,7 +873,7 @@
           <a:p>
             <a:fld id="{A43BE092-F41F-4496-B850-05C99CFB8755}" type="datetimeFigureOut">
               <a:rPr lang="en-IN" smtClean="0"/>
-              <a:t>12-05-2026</a:t>
+              <a:t>16-05-2026</a:t>
             </a:fld>
             <a:endParaRPr lang="en-IN"/>
           </a:p>
@@ -1149,7 +1149,7 @@
           <a:p>
             <a:fld id="{A43BE092-F41F-4496-B850-05C99CFB8755}" type="datetimeFigureOut">
               <a:rPr lang="en-IN" smtClean="0"/>
-              <a:t>12-05-2026</a:t>
+              <a:t>16-05-2026</a:t>
             </a:fld>
             <a:endParaRPr lang="en-IN"/>
           </a:p>
@@ -1417,7 +1417,7 @@
           <a:p>
             <a:fld id="{A43BE092-F41F-4496-B850-05C99CFB8755}" type="datetimeFigureOut">
               <a:rPr lang="en-IN" smtClean="0"/>
-              <a:t>12-05-2026</a:t>
+              <a:t>16-05-2026</a:t>
             </a:fld>
             <a:endParaRPr lang="en-IN"/>
           </a:p>
@@ -1832,7 +1832,7 @@
           <a:p>
             <a:fld id="{A43BE092-F41F-4496-B850-05C99CFB8755}" type="datetimeFigureOut">
               <a:rPr lang="en-IN" smtClean="0"/>
-              <a:t>12-05-2026</a:t>
+              <a:t>16-05-2026</a:t>
             </a:fld>
             <a:endParaRPr lang="en-IN"/>
           </a:p>
@@ -1974,7 +1974,7 @@
           <a:p>
             <a:fld id="{A43BE092-F41F-4496-B850-05C99CFB8755}" type="datetimeFigureOut">
               <a:rPr lang="en-IN" smtClean="0"/>
-              <a:t>12-05-2026</a:t>
+              <a:t>16-05-2026</a:t>
             </a:fld>
             <a:endParaRPr lang="en-IN"/>
           </a:p>
@@ -2087,7 +2087,7 @@
           <a:p>
             <a:fld id="{A43BE092-F41F-4496-B850-05C99CFB8755}" type="datetimeFigureOut">
               <a:rPr lang="en-IN" smtClean="0"/>
-              <a:t>12-05-2026</a:t>
+              <a:t>16-05-2026</a:t>
             </a:fld>
             <a:endParaRPr lang="en-IN"/>
           </a:p>
@@ -2400,7 +2400,7 @@
           <a:p>
             <a:fld id="{A43BE092-F41F-4496-B850-05C99CFB8755}" type="datetimeFigureOut">
               <a:rPr lang="en-IN" smtClean="0"/>
-              <a:t>12-05-2026</a:t>
+              <a:t>16-05-2026</a:t>
             </a:fld>
             <a:endParaRPr lang="en-IN"/>
           </a:p>
@@ -2689,7 +2689,7 @@
           <a:p>
             <a:fld id="{A43BE092-F41F-4496-B850-05C99CFB8755}" type="datetimeFigureOut">
               <a:rPr lang="en-IN" smtClean="0"/>
-              <a:t>12-05-2026</a:t>
+              <a:t>16-05-2026</a:t>
             </a:fld>
             <a:endParaRPr lang="en-IN"/>
           </a:p>
@@ -2932,7 +2932,7 @@
           <a:p>
             <a:fld id="{A43BE092-F41F-4496-B850-05C99CFB8755}" type="datetimeFigureOut">
               <a:rPr lang="en-IN" smtClean="0"/>
-              <a:t>12-05-2026</a:t>
+              <a:t>16-05-2026</a:t>
             </a:fld>
             <a:endParaRPr lang="en-IN"/>
           </a:p>
@@ -4249,7 +4249,7 @@
         <p:spPr>
           <a:xfrm>
             <a:off x="157314" y="167148"/>
-            <a:ext cx="3342970" cy="4933220"/>
+            <a:ext cx="2713705" cy="4933220"/>
           </a:xfrm>
           <a:custGeom>
             <a:avLst/>
@@ -4461,7 +4461,7 @@
         <p:spPr>
           <a:xfrm>
             <a:off x="157314" y="4607584"/>
-            <a:ext cx="3342970" cy="914400"/>
+            <a:ext cx="2713705" cy="914400"/>
           </a:xfrm>
           <a:prstGeom prst="rect">
             <a:avLst/>
@@ -4529,10 +4529,10 @@
       </p:sp>
       <p:sp>
         <p:nvSpPr>
-          <p:cNvPr id="14" name="Freeform: Shape 13">
-            <a:extLst>
-              <a:ext uri="{FF2B5EF4-FFF2-40B4-BE49-F238E27FC236}">
-                <a16:creationId xmlns:a16="http://schemas.microsoft.com/office/drawing/2014/main" id="{C6DDD590-3340-E626-E89C-6E51002A93A2}"/>
+          <p:cNvPr id="15" name="Rectangle: Rounded Corners 14">
+            <a:extLst>
+              <a:ext uri="{FF2B5EF4-FFF2-40B4-BE49-F238E27FC236}">
+                <a16:creationId xmlns:a16="http://schemas.microsoft.com/office/drawing/2014/main" id="{304CA411-5AC1-4F97-3BA8-B1E61C395CFB}"/>
               </a:ext>
             </a:extLst>
           </p:cNvPr>
@@ -4540,33 +4540,116 @@
           <p:nvPr/>
         </p:nvSpPr>
         <p:spPr>
-          <a:xfrm rot="-540000">
-            <a:off x="122853" y="96125"/>
-            <a:ext cx="3382544" cy="2463526"/>
+          <a:xfrm>
+            <a:off x="334297" y="3065682"/>
+            <a:ext cx="717755" cy="709905"/>
+          </a:xfrm>
+          <a:prstGeom prst="roundRect">
+            <a:avLst/>
+          </a:prstGeom>
+          <a:ln>
+            <a:noFill/>
+          </a:ln>
+          <a:effectLst>
+            <a:outerShdw blurRad="63500" dist="38100" dir="5400000" sx="102000" sy="102000" algn="t" rotWithShape="0">
+              <a:prstClr val="black">
+                <a:alpha val="40000"/>
+              </a:prstClr>
+            </a:outerShdw>
+          </a:effectLst>
+        </p:spPr>
+        <p:style>
+          <a:lnRef idx="2">
+            <a:schemeClr val="dk1"/>
+          </a:lnRef>
+          <a:fillRef idx="1">
+            <a:schemeClr val="lt1"/>
+          </a:fillRef>
+          <a:effectRef idx="0">
+            <a:schemeClr val="dk1"/>
+          </a:effectRef>
+          <a:fontRef idx="minor">
+            <a:schemeClr val="dk1"/>
+          </a:fontRef>
+        </p:style>
+        <p:txBody>
+          <a:bodyPr rtlCol="0" anchor="ctr"/>
+          <a:lstStyle/>
+          <a:p>
+            <a:pPr marL="0" marR="0" lvl="0" indent="0" algn="ctr" defTabSz="914400" rtl="0" eaLnBrk="1" fontAlgn="auto" latinLnBrk="0" hangingPunct="1">
+              <a:lnSpc>
+                <a:spcPct val="100000"/>
+              </a:lnSpc>
+              <a:spcBef>
+                <a:spcPts val="0"/>
+              </a:spcBef>
+              <a:spcAft>
+                <a:spcPts val="0"/>
+              </a:spcAft>
+              <a:buClrTx/>
+              <a:buSzTx/>
+              <a:buFontTx/>
+              <a:buNone/>
+              <a:tabLst/>
+              <a:defRPr/>
+            </a:pPr>
+            <a:endParaRPr kumimoji="0" lang="en-IN" sz="1800" b="0" i="0" u="none" strike="noStrike" kern="1200" cap="none" spc="0" normalizeH="0" baseline="0" noProof="0">
+              <a:ln>
+                <a:noFill/>
+              </a:ln>
+              <a:solidFill>
+                <a:prstClr val="black"/>
+              </a:solidFill>
+              <a:effectLst/>
+              <a:uLnTx/>
+              <a:uFillTx/>
+              <a:latin typeface="Calibri" panose="020F0502020204030204"/>
+              <a:ea typeface="+mn-ea"/>
+              <a:cs typeface="+mn-cs"/>
+            </a:endParaRPr>
+          </a:p>
+        </p:txBody>
+      </p:sp>
+      <p:sp>
+        <p:nvSpPr>
+          <p:cNvPr id="6" name="Freeform: Shape 5">
+            <a:extLst>
+              <a:ext uri="{FF2B5EF4-FFF2-40B4-BE49-F238E27FC236}">
+                <a16:creationId xmlns:a16="http://schemas.microsoft.com/office/drawing/2014/main" id="{342FF97E-E734-BD26-F67B-8F071D5DA32B}"/>
+              </a:ext>
+            </a:extLst>
+          </p:cNvPr>
+          <p:cNvSpPr/>
+          <p:nvPr/>
+        </p:nvSpPr>
+        <p:spPr>
+          <a:xfrm rot="21046907">
+            <a:off x="133793" y="109481"/>
+            <a:ext cx="2743235" cy="2101707"/>
           </a:xfrm>
           <a:custGeom>
             <a:avLst/>
             <a:gdLst>
-              <a:gd name="csX0" fmla="*/ 537667 w 2781040"/>
-              <a:gd name="csY0" fmla="*/ 3256 h 2076461"/>
-              <a:gd name="csX1" fmla="*/ 2560565 w 2781040"/>
-              <a:gd name="csY1" fmla="*/ 323651 h 2076461"/>
-              <a:gd name="csX2" fmla="*/ 2777785 w 2781040"/>
-              <a:gd name="csY2" fmla="*/ 622629 h 2076461"/>
-              <a:gd name="csX3" fmla="*/ 2575199 w 2781040"/>
-              <a:gd name="csY3" fmla="*/ 1901702 h 2076461"/>
-              <a:gd name="csX4" fmla="*/ 2404529 w 2781040"/>
-              <a:gd name="csY4" fmla="*/ 1955539 h 2076461"/>
-              <a:gd name="csX5" fmla="*/ 1489838 w 2781040"/>
-              <a:gd name="csY5" fmla="*/ 2076461 h 2076461"/>
-              <a:gd name="csX6" fmla="*/ 175981 w 2781040"/>
-              <a:gd name="csY6" fmla="*/ 1813667 h 2076461"/>
-              <a:gd name="csX7" fmla="*/ 0 w 2781040"/>
-              <a:gd name="csY7" fmla="*/ 1727496 h 2076461"/>
-              <a:gd name="csX8" fmla="*/ 238689 w 2781040"/>
-              <a:gd name="csY8" fmla="*/ 220476 h 2076461"/>
-              <a:gd name="csX9" fmla="*/ 537667 w 2781040"/>
-              <a:gd name="csY9" fmla="*/ 3256 h 2076461"/>
+              <a:gd name="csX0" fmla="*/ 595809 w 2642129"/>
+              <a:gd name="csY0" fmla="*/ 4154 h 2077744"/>
+              <a:gd name="csX1" fmla="*/ 2375092 w 2642129"/>
+              <a:gd name="csY1" fmla="*/ 292915 h 2077744"/>
+              <a:gd name="csX2" fmla="*/ 2637976 w 2642129"/>
+              <a:gd name="csY2" fmla="*/ 657657 h 2077744"/>
+              <a:gd name="csX3" fmla="*/ 2456405 w 2642129"/>
+              <a:gd name="csY3" fmla="*/ 1776457 h 2077744"/>
+              <a:gd name="csX4" fmla="*/ 2426489 w 2642129"/>
+              <a:gd name="csY4" fmla="*/ 1794800 h 2077744"/>
+              <a:gd name="csX5" fmla="*/ 1296792 w 2642129"/>
+              <a:gd name="csY5" fmla="*/ 2077744 h 2077744"/>
+              <a:gd name="csX6" fmla="*/ 11548 w 2642129"/>
+              <a:gd name="csY6" fmla="*/ 1699426 h 2077744"/>
+              <a:gd name="csX7" fmla="*/ 0 w 2642129"/>
+              <a:gd name="csY7" fmla="*/ 1690820 h 2077744"/>
+              <a:gd name="csX8" fmla="*/ 231067 w 2642129"/>
+              <a:gd name="csY8" fmla="*/ 267038 h 2077744"/>
+              <a:gd name="csX9" fmla="*/ 595809 w 2642129"/>
+              <a:gd name="csY9" fmla="*/ 4154 h 2077744"/>
             </a:gdLst>
             <a:ahLst/>
             <a:cxnLst>
@@ -4603,44 +4686,44 @@
             </a:cxnLst>
             <a:rect l="l" t="t" r="r" b="b"/>
             <a:pathLst>
-              <a:path w="2781040" h="2076461">
+              <a:path w="2642129" h="2077744">
                 <a:moveTo>
-                  <a:pt x="537667" y="3256"/>
+                  <a:pt x="595809" y="4154"/>
                 </a:moveTo>
                 <a:lnTo>
-                  <a:pt x="2560565" y="323651"/>
+                  <a:pt x="2375092" y="292915"/>
                 </a:lnTo>
                 <a:cubicBezTo>
-                  <a:pt x="2703109" y="346228"/>
-                  <a:pt x="2800362" y="480085"/>
-                  <a:pt x="2777785" y="622629"/>
+                  <a:pt x="2548406" y="321042"/>
+                  <a:pt x="2666103" y="484343"/>
+                  <a:pt x="2637976" y="657657"/>
                 </a:cubicBezTo>
                 <a:lnTo>
-                  <a:pt x="2575199" y="1901702"/>
+                  <a:pt x="2456405" y="1776457"/>
                 </a:lnTo>
                 <a:lnTo>
-                  <a:pt x="2404529" y="1955539"/>
+                  <a:pt x="2426489" y="1794800"/>
                 </a:lnTo>
                 <a:cubicBezTo>
-                  <a:pt x="2123390" y="2033403"/>
-                  <a:pt x="1814293" y="2076461"/>
-                  <a:pt x="1489838" y="2076461"/>
+                  <a:pt x="2104010" y="1973436"/>
+                  <a:pt x="1715257" y="2077744"/>
+                  <a:pt x="1296792" y="2077744"/>
                 </a:cubicBezTo>
                 <a:cubicBezTo>
-                  <a:pt x="1003156" y="2076461"/>
-                  <a:pt x="551029" y="1979581"/>
-                  <a:pt x="175981" y="1813667"/>
+                  <a:pt x="808583" y="2077744"/>
+                  <a:pt x="360815" y="1935769"/>
+                  <a:pt x="11548" y="1699426"/>
                 </a:cubicBezTo>
                 <a:lnTo>
-                  <a:pt x="0" y="1727496"/>
+                  <a:pt x="0" y="1690820"/>
                 </a:lnTo>
                 <a:lnTo>
-                  <a:pt x="238689" y="220476"/>
+                  <a:pt x="231067" y="267038"/>
                 </a:lnTo>
                 <a:cubicBezTo>
-                  <a:pt x="261266" y="77931"/>
-                  <a:pt x="395122" y="-19321"/>
-                  <a:pt x="537667" y="3256"/>
+                  <a:pt x="259194" y="93723"/>
+                  <a:pt x="422495" y="-23974"/>
+                  <a:pt x="595809" y="4154"/>
                 </a:cubicBezTo>
                 <a:close/>
               </a:path>
@@ -4677,46 +4760,17 @@
           </a:bodyPr>
           <a:lstStyle/>
           <a:p>
-            <a:pPr marL="0" marR="0" lvl="0" indent="0" algn="ctr" defTabSz="914400" rtl="0" eaLnBrk="1" fontAlgn="auto" latinLnBrk="0" hangingPunct="1">
-              <a:lnSpc>
-                <a:spcPct val="100000"/>
-              </a:lnSpc>
-              <a:spcBef>
-                <a:spcPts val="0"/>
-              </a:spcBef>
-              <a:spcAft>
-                <a:spcPts val="0"/>
-              </a:spcAft>
-              <a:buClrTx/>
-              <a:buSzTx/>
-              <a:buFontTx/>
-              <a:buNone/>
-              <a:tabLst/>
-              <a:defRPr/>
-            </a:pPr>
-            <a:endParaRPr kumimoji="0" lang="en-IN" sz="1800" b="0" i="0" u="none" strike="noStrike" kern="1200" cap="none" spc="0" normalizeH="0" baseline="0" noProof="0">
-              <a:ln>
-                <a:noFill/>
-              </a:ln>
-              <a:solidFill>
-                <a:prstClr val="white"/>
-              </a:solidFill>
-              <a:effectLst/>
-              <a:uLnTx/>
-              <a:uFillTx/>
-              <a:latin typeface="Calibri" panose="020F0502020204030204"/>
-              <a:ea typeface="+mn-ea"/>
-              <a:cs typeface="+mn-cs"/>
-            </a:endParaRPr>
-          </a:p>
-        </p:txBody>
-      </p:sp>
-      <p:sp>
-        <p:nvSpPr>
-          <p:cNvPr id="15" name="Rectangle: Rounded Corners 14">
-            <a:extLst>
-              <a:ext uri="{FF2B5EF4-FFF2-40B4-BE49-F238E27FC236}">
-                <a16:creationId xmlns:a16="http://schemas.microsoft.com/office/drawing/2014/main" id="{304CA411-5AC1-4F97-3BA8-B1E61C395CFB}"/>
+            <a:pPr algn="ctr"/>
+            <a:endParaRPr lang="en-IN"/>
+          </a:p>
+        </p:txBody>
+      </p:sp>
+      <p:sp>
+        <p:nvSpPr>
+          <p:cNvPr id="7" name="Rectangle: Rounded Corners 6">
+            <a:extLst>
+              <a:ext uri="{FF2B5EF4-FFF2-40B4-BE49-F238E27FC236}">
+                <a16:creationId xmlns:a16="http://schemas.microsoft.com/office/drawing/2014/main" id="{87FFE3EB-6121-91C6-A8DB-EB54081FF0C2}"/>
               </a:ext>
             </a:extLst>
           </p:cNvPr>
@@ -4725,8 +4779,8 @@
         </p:nvSpPr>
         <p:spPr>
           <a:xfrm>
-            <a:off x="314632" y="3618395"/>
-            <a:ext cx="914400" cy="914400"/>
+            <a:off x="1199534" y="3075513"/>
+            <a:ext cx="717755" cy="709905"/>
           </a:xfrm>
           <a:prstGeom prst="roundRect">
             <a:avLst/>
@@ -4796,10 +4850,10 @@
       </p:sp>
       <p:sp>
         <p:nvSpPr>
-          <p:cNvPr id="18" name="Rectangle: Rounded Corners 17">
-            <a:extLst>
-              <a:ext uri="{FF2B5EF4-FFF2-40B4-BE49-F238E27FC236}">
-                <a16:creationId xmlns:a16="http://schemas.microsoft.com/office/drawing/2014/main" id="{64D1938E-650A-E5A2-4F2B-33F494ABB627}"/>
+          <p:cNvPr id="8" name="Rectangle: Rounded Corners 7">
+            <a:extLst>
+              <a:ext uri="{FF2B5EF4-FFF2-40B4-BE49-F238E27FC236}">
+                <a16:creationId xmlns:a16="http://schemas.microsoft.com/office/drawing/2014/main" id="{099E0C03-3E1B-5E61-68AD-1E19430C4912}"/>
               </a:ext>
             </a:extLst>
           </p:cNvPr>
@@ -4808,91 +4862,8 @@
         </p:nvSpPr>
         <p:spPr>
           <a:xfrm>
-            <a:off x="1381428" y="3618395"/>
-            <a:ext cx="914400" cy="914400"/>
-          </a:xfrm>
-          <a:prstGeom prst="roundRect">
-            <a:avLst/>
-          </a:prstGeom>
-          <a:ln>
-            <a:noFill/>
-          </a:ln>
-          <a:effectLst>
-            <a:outerShdw blurRad="63500" dist="38100" dir="5400000" sx="102000" sy="102000" algn="t" rotWithShape="0">
-              <a:prstClr val="black">
-                <a:alpha val="40000"/>
-              </a:prstClr>
-            </a:outerShdw>
-          </a:effectLst>
-        </p:spPr>
-        <p:style>
-          <a:lnRef idx="2">
-            <a:schemeClr val="dk1"/>
-          </a:lnRef>
-          <a:fillRef idx="1">
-            <a:schemeClr val="lt1"/>
-          </a:fillRef>
-          <a:effectRef idx="0">
-            <a:schemeClr val="dk1"/>
-          </a:effectRef>
-          <a:fontRef idx="minor">
-            <a:schemeClr val="dk1"/>
-          </a:fontRef>
-        </p:style>
-        <p:txBody>
-          <a:bodyPr rtlCol="0" anchor="ctr"/>
-          <a:lstStyle/>
-          <a:p>
-            <a:pPr marL="0" marR="0" lvl="0" indent="0" algn="ctr" defTabSz="914400" rtl="0" eaLnBrk="1" fontAlgn="auto" latinLnBrk="0" hangingPunct="1">
-              <a:lnSpc>
-                <a:spcPct val="100000"/>
-              </a:lnSpc>
-              <a:spcBef>
-                <a:spcPts val="0"/>
-              </a:spcBef>
-              <a:spcAft>
-                <a:spcPts val="0"/>
-              </a:spcAft>
-              <a:buClrTx/>
-              <a:buSzTx/>
-              <a:buFontTx/>
-              <a:buNone/>
-              <a:tabLst/>
-              <a:defRPr/>
-            </a:pPr>
-            <a:endParaRPr kumimoji="0" lang="en-IN" sz="1800" b="0" i="0" u="none" strike="noStrike" kern="1200" cap="none" spc="0" normalizeH="0" baseline="0" noProof="0">
-              <a:ln>
-                <a:noFill/>
-              </a:ln>
-              <a:solidFill>
-                <a:prstClr val="black"/>
-              </a:solidFill>
-              <a:effectLst/>
-              <a:uLnTx/>
-              <a:uFillTx/>
-              <a:latin typeface="Calibri" panose="020F0502020204030204"/>
-              <a:ea typeface="+mn-ea"/>
-              <a:cs typeface="+mn-cs"/>
-            </a:endParaRPr>
-          </a:p>
-        </p:txBody>
-      </p:sp>
-      <p:sp>
-        <p:nvSpPr>
-          <p:cNvPr id="19" name="Rectangle: Rounded Corners 18">
-            <a:extLst>
-              <a:ext uri="{FF2B5EF4-FFF2-40B4-BE49-F238E27FC236}">
-                <a16:creationId xmlns:a16="http://schemas.microsoft.com/office/drawing/2014/main" id="{F424094F-35A5-D28E-F3C3-DF7713EB155E}"/>
-              </a:ext>
-            </a:extLst>
-          </p:cNvPr>
-          <p:cNvSpPr/>
-          <p:nvPr/>
-        </p:nvSpPr>
-        <p:spPr>
-          <a:xfrm>
-            <a:off x="2448224" y="3618395"/>
-            <a:ext cx="914400" cy="914400"/>
+            <a:off x="2074603" y="3065681"/>
+            <a:ext cx="717755" cy="709905"/>
           </a:xfrm>
           <a:prstGeom prst="roundRect">
             <a:avLst/>

</xml_diff>